<commit_message>
chore: gitignore - PPTX
</commit_message>
<xml_diff>
--- a/skills/suf/cmux_suf_orchestration.pptx
+++ b/skills/suf/cmux_suf_orchestration.pptx
@@ -12,9 +12,11 @@
     <p:sldId id="260" r:id="rId6"/>
     <p:sldId id="261" r:id="rId7"/>
     <p:sldId id="262" r:id="rId8"/>
+    <p:sldId id="263" r:id="rId9"/>
+    <p:sldId id="264" r:id="rId10"/>
   </p:sldIdLst>
   <p:notesMasterIdLst>
-    <p:notesMasterId r:id="rId9"/>
+    <p:notesMasterId r:id="rId11"/>
   </p:notesMasterIdLst>
   <p:sldSz cx="12192000" cy="6858000"/>
   <p:notesSz cx="6858000" cy="12192000"/>
@@ -1078,6 +1080,182 @@
 </p:notes>
 </file>
 
+<file path=ppt/notesSlides/notesSlide8.xml><?xml version="1.0" encoding="utf-8"?>
+<p:notes xmlns:a="http://schemas.openxmlformats.org/drawingml/2006/main" xmlns:r="http://schemas.openxmlformats.org/officeDocument/2006/relationships" xmlns:p="http://schemas.openxmlformats.org/presentationml/2006/main">
+  <p:cSld>
+    <p:spTree>
+      <p:nvGrpSpPr>
+        <p:cNvPr id="1" name=""/>
+        <p:cNvGrpSpPr/>
+        <p:nvPr/>
+      </p:nvGrpSpPr>
+      <p:grpSpPr>
+        <a:xfrm>
+          <a:off x="0" y="0"/>
+          <a:ext cx="0" cy="0"/>
+          <a:chOff x="0" y="0"/>
+          <a:chExt cx="0" cy="0"/>
+        </a:xfrm>
+      </p:grpSpPr>
+      <p:sp>
+        <p:nvSpPr>
+          <p:cNvPr id="2" name="Slide Image Placeholder 1"/>
+          <p:cNvSpPr>
+            <a:spLocks noGrp="1" noRot="1" noChangeAspect="1"/>
+          </p:cNvSpPr>
+          <p:nvPr>
+            <p:ph type="sldImg"/>
+          </p:nvPr>
+        </p:nvSpPr>
+        <p:spPr/>
+      </p:sp>
+      <p:sp>
+        <p:nvSpPr>
+          <p:cNvPr id="3" name="Notes Placeholder 2"/>
+          <p:cNvSpPr>
+            <a:spLocks noGrp="1"/>
+          </p:cNvSpPr>
+          <p:nvPr>
+            <p:ph type="body" idx="1"/>
+          </p:nvPr>
+        </p:nvSpPr>
+        <p:spPr/>
+        <p:txBody>
+          <a:bodyPr/>
+          <a:lstStyle/>
+          <a:p>
+            <a:r>
+              <a:rPr lang="en-US" dirty="0"/>
+              <a:t/>
+            </a:r>
+            <a:endParaRPr lang="en-US" dirty="0"/>
+          </a:p>
+        </p:txBody>
+      </p:sp>
+      <p:sp>
+        <p:nvSpPr>
+          <p:cNvPr id="4" name="Slide Number Placeholder 3"/>
+          <p:cNvSpPr>
+            <a:spLocks noGrp="1"/>
+          </p:cNvSpPr>
+          <p:nvPr>
+            <p:ph type="sldNum" sz="quarter" idx="10"/>
+          </p:nvPr>
+        </p:nvSpPr>
+        <p:spPr/>
+        <p:txBody>
+          <a:bodyPr/>
+          <a:lstStyle/>
+          <a:p>
+            <a:fld id="{F7021451-1387-4CA6-816F-3879F97B5CBC}" type="slidenum">
+              <a:rPr lang="en-US"/>
+              <a:t>8</a:t>
+            </a:fld>
+            <a:endParaRPr lang="en-US"/>
+          </a:p>
+        </p:txBody>
+      </p:sp>
+    </p:spTree>
+    <p:extLst>
+      <p:ext uri="{BB962C8B-B14F-4D97-AF65-F5344CB8AC3E}">
+        <p14:creationId xmlns:p14="http://schemas.microsoft.com/office/powerpoint/2010/main" val="1024086991"/>
+      </p:ext>
+    </p:extLst>
+  </p:cSld>
+  <p:clrMapOvr>
+    <a:masterClrMapping/>
+  </p:clrMapOvr>
+</p:notes>
+</file>
+
+<file path=ppt/notesSlides/notesSlide9.xml><?xml version="1.0" encoding="utf-8"?>
+<p:notes xmlns:a="http://schemas.openxmlformats.org/drawingml/2006/main" xmlns:r="http://schemas.openxmlformats.org/officeDocument/2006/relationships" xmlns:p="http://schemas.openxmlformats.org/presentationml/2006/main">
+  <p:cSld>
+    <p:spTree>
+      <p:nvGrpSpPr>
+        <p:cNvPr id="1" name=""/>
+        <p:cNvGrpSpPr/>
+        <p:nvPr/>
+      </p:nvGrpSpPr>
+      <p:grpSpPr>
+        <a:xfrm>
+          <a:off x="0" y="0"/>
+          <a:ext cx="0" cy="0"/>
+          <a:chOff x="0" y="0"/>
+          <a:chExt cx="0" cy="0"/>
+        </a:xfrm>
+      </p:grpSpPr>
+      <p:sp>
+        <p:nvSpPr>
+          <p:cNvPr id="2" name="Slide Image Placeholder 1"/>
+          <p:cNvSpPr>
+            <a:spLocks noGrp="1" noRot="1" noChangeAspect="1"/>
+          </p:cNvSpPr>
+          <p:nvPr>
+            <p:ph type="sldImg"/>
+          </p:nvPr>
+        </p:nvSpPr>
+        <p:spPr/>
+      </p:sp>
+      <p:sp>
+        <p:nvSpPr>
+          <p:cNvPr id="3" name="Notes Placeholder 2"/>
+          <p:cNvSpPr>
+            <a:spLocks noGrp="1"/>
+          </p:cNvSpPr>
+          <p:nvPr>
+            <p:ph type="body" idx="1"/>
+          </p:nvPr>
+        </p:nvSpPr>
+        <p:spPr/>
+        <p:txBody>
+          <a:bodyPr/>
+          <a:lstStyle/>
+          <a:p>
+            <a:r>
+              <a:rPr lang="en-US" dirty="0"/>
+              <a:t/>
+            </a:r>
+            <a:endParaRPr lang="en-US" dirty="0"/>
+          </a:p>
+        </p:txBody>
+      </p:sp>
+      <p:sp>
+        <p:nvSpPr>
+          <p:cNvPr id="4" name="Slide Number Placeholder 3"/>
+          <p:cNvSpPr>
+            <a:spLocks noGrp="1"/>
+          </p:cNvSpPr>
+          <p:nvPr>
+            <p:ph type="sldNum" sz="quarter" idx="10"/>
+          </p:nvPr>
+        </p:nvSpPr>
+        <p:spPr/>
+        <p:txBody>
+          <a:bodyPr/>
+          <a:lstStyle/>
+          <a:p>
+            <a:fld id="{F7021451-1387-4CA6-816F-3879F97B5CBC}" type="slidenum">
+              <a:rPr lang="en-US"/>
+              <a:t>9</a:t>
+            </a:fld>
+            <a:endParaRPr lang="en-US"/>
+          </a:p>
+        </p:txBody>
+      </p:sp>
+    </p:spTree>
+    <p:extLst>
+      <p:ext uri="{BB962C8B-B14F-4D97-AF65-F5344CB8AC3E}">
+        <p14:creationId xmlns:p14="http://schemas.microsoft.com/office/powerpoint/2010/main" val="1024086991"/>
+      </p:ext>
+    </p:extLst>
+  </p:cSld>
+  <p:clrMapOvr>
+    <a:masterClrMapping/>
+  </p:clrMapOvr>
+</p:notes>
+</file>
+
 <file path=ppt/slideLayouts/slideLayout1.xml><?xml version="1.0" encoding="utf-8"?>
 <p:sldLayout xmlns:a="http://schemas.openxmlformats.org/drawingml/2006/main" xmlns:r="http://schemas.openxmlformats.org/officeDocument/2006/relationships" xmlns:p="http://schemas.openxmlformats.org/presentationml/2006/main" preserve="1">
   <p:cSld name="DEFAULT">
@@ -2029,7 +2207,7 @@
                 <a:ea typeface="Consolas" pitchFamily="34" charset="-122"/>
                 <a:cs typeface="Consolas" pitchFamily="34" charset="-120"/>
               </a:rPr>
-              <a:t>7-slide overview</a:t>
+              <a:t>9-slide overview</a:t>
             </a:r>
             <a:endParaRPr lang="en-US" sz="1000" dirty="0"/>
           </a:p>
@@ -9554,6 +9732,1832 @@
               <a:t>cross-workspace 미지원 · 사용자가 쓰는 surface 에 worker 금지 · LLM sidecar 는 permission-skip 모드 필요 · 응답 4KB 초과 truncate</a:t>
             </a:r>
             <a:endParaRPr lang="en-US" sz="1100" dirty="0"/>
+          </a:p>
+        </p:txBody>
+      </p:sp>
+    </p:spTree>
+  </p:cSld>
+  <p:clrMapOvr>
+    <a:masterClrMapping/>
+  </p:clrMapOvr>
+</p:sld>
+</file>
+
+<file path=ppt/slides/slide8.xml><?xml version="1.0" encoding="utf-8"?>
+<p:sld xmlns:a="http://schemas.openxmlformats.org/drawingml/2006/main" xmlns:r="http://schemas.openxmlformats.org/officeDocument/2006/relationships" xmlns:p="http://schemas.openxmlformats.org/presentationml/2006/main">
+  <p:cSld name="Slide 8">
+    <p:bg>
+      <p:bgPr>
+        <a:solidFill>
+          <a:srgbClr val="0D1117"/>
+        </a:solidFill>
+      </p:bgPr>
+    </p:bg>
+    <p:spTree>
+      <p:nvGrpSpPr>
+        <p:cNvPr id="1" name=""/>
+        <p:cNvGrpSpPr/>
+        <p:nvPr/>
+      </p:nvGrpSpPr>
+      <p:grpSpPr>
+        <a:xfrm>
+          <a:off x="0" y="0"/>
+          <a:ext cx="0" cy="0"/>
+          <a:chOff x="0" y="0"/>
+          <a:chExt cx="0" cy="0"/>
+        </a:xfrm>
+      </p:grpSpPr>
+      <p:sp>
+        <p:nvSpPr>
+          <p:cNvPr id="2" name="Text 0"/>
+          <p:cNvSpPr/>
+          <p:nvPr/>
+        </p:nvSpPr>
+        <p:spPr>
+          <a:xfrm>
+            <a:off x="548640" y="411480"/>
+            <a:ext cx="7315200" cy="365760"/>
+          </a:xfrm>
+          <a:prstGeom prst="rect">
+            <a:avLst/>
+          </a:prstGeom>
+          <a:noFill/>
+          <a:ln/>
+        </p:spPr>
+        <p:txBody>
+          <a:bodyPr wrap="square" lIns="0" tIns="0" rIns="0" bIns="0" rtlCol="0" anchor="ctr"/>
+          <a:lstStyle/>
+          <a:p>
+            <a:pPr algn="l" indent="0" marL="0">
+              <a:buNone/>
+            </a:pPr>
+            <a:r>
+              <a:rPr lang="en-US" sz="1300" b="1" dirty="0">
+                <a:solidFill>
+                  <a:srgbClr val="3FB950"/>
+                </a:solidFill>
+                <a:latin typeface="Consolas" pitchFamily="34" charset="0"/>
+                <a:ea typeface="Consolas" pitchFamily="34" charset="-122"/>
+                <a:cs typeface="Consolas" pitchFamily="34" charset="-120"/>
+              </a:rPr>
+              <a:t>07</a:t>
+            </a:r>
+            <a:pPr algn="l" indent="0" marL="0">
+              <a:buNone/>
+            </a:pPr>
+            <a:r>
+              <a:rPr lang="en-US" sz="1300" dirty="0">
+                <a:solidFill>
+                  <a:srgbClr val="8B949E"/>
+                </a:solidFill>
+                <a:latin typeface="Consolas" pitchFamily="34" charset="0"/>
+                <a:ea typeface="Consolas" pitchFamily="34" charset="-122"/>
+                <a:cs typeface="Consolas" pitchFamily="34" charset="-120"/>
+              </a:rPr>
+              <a:t>  IMPLICATIONS</a:t>
+            </a:r>
+            <a:endParaRPr lang="en-US" sz="1300" dirty="0"/>
+          </a:p>
+        </p:txBody>
+      </p:sp>
+      <p:sp>
+        <p:nvSpPr>
+          <p:cNvPr id="3" name="Text 1"/>
+          <p:cNvSpPr/>
+          <p:nvPr/>
+        </p:nvSpPr>
+        <p:spPr>
+          <a:xfrm>
+            <a:off x="548640" y="777240"/>
+            <a:ext cx="11064240" cy="822960"/>
+          </a:xfrm>
+          <a:prstGeom prst="rect">
+            <a:avLst/>
+          </a:prstGeom>
+          <a:noFill/>
+          <a:ln/>
+        </p:spPr>
+        <p:txBody>
+          <a:bodyPr wrap="square" lIns="0" tIns="0" rIns="0" bIns="0" rtlCol="0" anchor="ctr"/>
+          <a:lstStyle/>
+          <a:p>
+            <a:pPr algn="l" indent="0" marL="0">
+              <a:buNone/>
+            </a:pPr>
+            <a:r>
+              <a:rPr lang="en-US" sz="3200" b="1" dirty="0">
+                <a:solidFill>
+                  <a:srgbClr val="E6EDF3"/>
+                </a:solidFill>
+                <a:latin typeface="Calibri" pitchFamily="34" charset="0"/>
+                <a:ea typeface="Calibri" pitchFamily="34" charset="-122"/>
+                <a:cs typeface="Calibri" pitchFamily="34" charset="-120"/>
+              </a:rPr>
+              <a:t>시사점 — 앞으로의 개발 업무는 어떻게 바뀌나</a:t>
+            </a:r>
+            <a:endParaRPr lang="en-US" sz="3200" dirty="0"/>
+          </a:p>
+        </p:txBody>
+      </p:sp>
+      <p:sp>
+        <p:nvSpPr>
+          <p:cNvPr id="4" name="Shape 2"/>
+          <p:cNvSpPr/>
+          <p:nvPr/>
+        </p:nvSpPr>
+        <p:spPr>
+          <a:xfrm>
+            <a:off x="548640" y="1783080"/>
+            <a:ext cx="11091672" cy="932688"/>
+          </a:xfrm>
+          <a:prstGeom prst="rect">
+            <a:avLst/>
+          </a:prstGeom>
+          <a:solidFill>
+            <a:srgbClr val="161B22"/>
+          </a:solidFill>
+          <a:ln w="12700">
+            <a:solidFill>
+              <a:srgbClr val="30363D"/>
+            </a:solidFill>
+            <a:prstDash val="solid"/>
+          </a:ln>
+        </p:spPr>
+      </p:sp>
+      <p:sp>
+        <p:nvSpPr>
+          <p:cNvPr id="5" name="Shape 3"/>
+          <p:cNvSpPr/>
+          <p:nvPr/>
+        </p:nvSpPr>
+        <p:spPr>
+          <a:xfrm>
+            <a:off x="548640" y="1783080"/>
+            <a:ext cx="73152" cy="932688"/>
+          </a:xfrm>
+          <a:prstGeom prst="rect">
+            <a:avLst/>
+          </a:prstGeom>
+          <a:solidFill>
+            <a:srgbClr val="3FB950"/>
+          </a:solidFill>
+          <a:ln/>
+        </p:spPr>
+      </p:sp>
+      <p:sp>
+        <p:nvSpPr>
+          <p:cNvPr id="6" name="Text 4"/>
+          <p:cNvSpPr/>
+          <p:nvPr/>
+        </p:nvSpPr>
+        <p:spPr>
+          <a:xfrm>
+            <a:off x="868680" y="1874520"/>
+            <a:ext cx="2743200" cy="749808"/>
+          </a:xfrm>
+          <a:prstGeom prst="rect">
+            <a:avLst/>
+          </a:prstGeom>
+          <a:noFill/>
+          <a:ln/>
+        </p:spPr>
+        <p:txBody>
+          <a:bodyPr wrap="square" lIns="0" tIns="0" rIns="0" bIns="0" rtlCol="0" anchor="ctr"/>
+          <a:lstStyle/>
+          <a:p>
+            <a:pPr indent="0" marL="0">
+              <a:buNone/>
+            </a:pPr>
+            <a:r>
+              <a:rPr lang="en-US" sz="1500" b="1" dirty="0">
+                <a:solidFill>
+                  <a:srgbClr val="3FB950"/>
+                </a:solidFill>
+                <a:latin typeface="Calibri" pitchFamily="34" charset="0"/>
+                <a:ea typeface="Calibri" pitchFamily="34" charset="-122"/>
+                <a:cs typeface="Calibri" pitchFamily="34" charset="-120"/>
+              </a:rPr>
+              <a:t>역할의 재정의</a:t>
+            </a:r>
+            <a:endParaRPr lang="en-US" sz="1500" dirty="0"/>
+          </a:p>
+        </p:txBody>
+      </p:sp>
+      <p:sp>
+        <p:nvSpPr>
+          <p:cNvPr id="7" name="Text 5"/>
+          <p:cNvSpPr/>
+          <p:nvPr/>
+        </p:nvSpPr>
+        <p:spPr>
+          <a:xfrm>
+            <a:off x="3749040" y="1874520"/>
+            <a:ext cx="7589520" cy="749808"/>
+          </a:xfrm>
+          <a:prstGeom prst="rect">
+            <a:avLst/>
+          </a:prstGeom>
+          <a:noFill/>
+          <a:ln/>
+        </p:spPr>
+        <p:txBody>
+          <a:bodyPr wrap="square" lIns="0" tIns="0" rIns="0" bIns="0" rtlCol="0" anchor="ctr"/>
+          <a:lstStyle/>
+          <a:p>
+            <a:pPr indent="0" marL="0">
+              <a:lnSpc>
+                <a:spcPct val="125000"/>
+              </a:lnSpc>
+              <a:spcAft>
+                <a:spcPts val="300"/>
+              </a:spcAft>
+              <a:buNone/>
+            </a:pPr>
+            <a:r>
+              <a:rPr lang="en-US" sz="1200" dirty="0">
+                <a:solidFill>
+                  <a:srgbClr val="E6EDF3"/>
+                </a:solidFill>
+                <a:latin typeface="Calibri" pitchFamily="34" charset="0"/>
+                <a:ea typeface="Calibri" pitchFamily="34" charset="-122"/>
+                <a:cs typeface="Calibri" pitchFamily="34" charset="-120"/>
+              </a:rPr>
+              <a:t>코드를 직접 치는 사람에서, 여러 에이전트를 지휘하고 산출물을 검증하는 오케스트레이터로 이동</a:t>
+            </a:r>
+            <a:endParaRPr lang="en-US" sz="1200" dirty="0"/>
+          </a:p>
+          <a:p>
+            <a:pPr indent="0" marL="0">
+              <a:lnSpc>
+                <a:spcPct val="125000"/>
+              </a:lnSpc>
+              <a:spcAft>
+                <a:spcPts val="300"/>
+              </a:spcAft>
+              <a:buNone/>
+            </a:pPr>
+            <a:r>
+              <a:rPr lang="en-US" sz="1200" dirty="0">
+                <a:solidFill>
+                  <a:srgbClr val="D29922"/>
+                </a:solidFill>
+                <a:latin typeface="Calibri" pitchFamily="34" charset="0"/>
+                <a:ea typeface="Calibri" pitchFamily="34" charset="-122"/>
+                <a:cs typeface="Calibri" pitchFamily="34" charset="-120"/>
+              </a:rPr>
+              <a:t>주의 — 검증·리뷰 역량이 새로운 병목이자 핵심 경쟁력이 된다</a:t>
+            </a:r>
+            <a:endParaRPr lang="en-US" sz="1200" dirty="0"/>
+          </a:p>
+        </p:txBody>
+      </p:sp>
+      <p:sp>
+        <p:nvSpPr>
+          <p:cNvPr id="8" name="Shape 6"/>
+          <p:cNvSpPr/>
+          <p:nvPr/>
+        </p:nvSpPr>
+        <p:spPr>
+          <a:xfrm>
+            <a:off x="548640" y="2825496"/>
+            <a:ext cx="11091672" cy="932688"/>
+          </a:xfrm>
+          <a:prstGeom prst="rect">
+            <a:avLst/>
+          </a:prstGeom>
+          <a:solidFill>
+            <a:srgbClr val="161B22"/>
+          </a:solidFill>
+          <a:ln w="12700">
+            <a:solidFill>
+              <a:srgbClr val="30363D"/>
+            </a:solidFill>
+            <a:prstDash val="solid"/>
+          </a:ln>
+        </p:spPr>
+      </p:sp>
+      <p:sp>
+        <p:nvSpPr>
+          <p:cNvPr id="9" name="Shape 7"/>
+          <p:cNvSpPr/>
+          <p:nvPr/>
+        </p:nvSpPr>
+        <p:spPr>
+          <a:xfrm>
+            <a:off x="548640" y="2825496"/>
+            <a:ext cx="73152" cy="932688"/>
+          </a:xfrm>
+          <a:prstGeom prst="rect">
+            <a:avLst/>
+          </a:prstGeom>
+          <a:solidFill>
+            <a:srgbClr val="58A6FF"/>
+          </a:solidFill>
+          <a:ln/>
+        </p:spPr>
+      </p:sp>
+      <p:sp>
+        <p:nvSpPr>
+          <p:cNvPr id="10" name="Text 8"/>
+          <p:cNvSpPr/>
+          <p:nvPr/>
+        </p:nvSpPr>
+        <p:spPr>
+          <a:xfrm>
+            <a:off x="868680" y="2916936"/>
+            <a:ext cx="2743200" cy="749808"/>
+          </a:xfrm>
+          <a:prstGeom prst="rect">
+            <a:avLst/>
+          </a:prstGeom>
+          <a:noFill/>
+          <a:ln/>
+        </p:spPr>
+        <p:txBody>
+          <a:bodyPr wrap="square" lIns="0" tIns="0" rIns="0" bIns="0" rtlCol="0" anchor="ctr"/>
+          <a:lstStyle/>
+          <a:p>
+            <a:pPr indent="0" marL="0">
+              <a:buNone/>
+            </a:pPr>
+            <a:r>
+              <a:rPr lang="en-US" sz="1500" b="1" dirty="0">
+                <a:solidFill>
+                  <a:srgbClr val="58A6FF"/>
+                </a:solidFill>
+                <a:latin typeface="Calibri" pitchFamily="34" charset="0"/>
+                <a:ea typeface="Calibri" pitchFamily="34" charset="-122"/>
+                <a:cs typeface="Calibri" pitchFamily="34" charset="-120"/>
+              </a:rPr>
+              <a:t>범위·속도의 확장</a:t>
+            </a:r>
+            <a:endParaRPr lang="en-US" sz="1500" dirty="0"/>
+          </a:p>
+        </p:txBody>
+      </p:sp>
+      <p:sp>
+        <p:nvSpPr>
+          <p:cNvPr id="11" name="Text 9"/>
+          <p:cNvSpPr/>
+          <p:nvPr/>
+        </p:nvSpPr>
+        <p:spPr>
+          <a:xfrm>
+            <a:off x="3749040" y="2916936"/>
+            <a:ext cx="7589520" cy="749808"/>
+          </a:xfrm>
+          <a:prstGeom prst="rect">
+            <a:avLst/>
+          </a:prstGeom>
+          <a:noFill/>
+          <a:ln/>
+        </p:spPr>
+        <p:txBody>
+          <a:bodyPr wrap="square" lIns="0" tIns="0" rIns="0" bIns="0" rtlCol="0" anchor="ctr"/>
+          <a:lstStyle/>
+          <a:p>
+            <a:pPr indent="0" marL="0">
+              <a:lnSpc>
+                <a:spcPct val="125000"/>
+              </a:lnSpc>
+              <a:spcAft>
+                <a:spcPts val="300"/>
+              </a:spcAft>
+              <a:buNone/>
+            </a:pPr>
+            <a:r>
+              <a:rPr lang="en-US" sz="1200" dirty="0">
+                <a:solidFill>
+                  <a:srgbClr val="E6EDF3"/>
+                </a:solidFill>
+                <a:latin typeface="Calibri" pitchFamily="34" charset="0"/>
+                <a:ea typeface="Calibri" pitchFamily="34" charset="-122"/>
+                <a:cs typeface="Calibri" pitchFamily="34" charset="-120"/>
+              </a:rPr>
+              <a:t>1인이 기획부터 배포까지 기능을 end-to-end 로 소유 — 프로토타입에서 프로덕션까지 단축</a:t>
+            </a:r>
+            <a:endParaRPr lang="en-US" sz="1200" dirty="0"/>
+          </a:p>
+          <a:p>
+            <a:pPr indent="0" marL="0">
+              <a:lnSpc>
+                <a:spcPct val="125000"/>
+              </a:lnSpc>
+              <a:spcAft>
+                <a:spcPts val="300"/>
+              </a:spcAft>
+              <a:buNone/>
+            </a:pPr>
+            <a:r>
+              <a:rPr lang="en-US" sz="1200" dirty="0">
+                <a:solidFill>
+                  <a:srgbClr val="D29922"/>
+                </a:solidFill>
+                <a:latin typeface="Calibri" pitchFamily="34" charset="0"/>
+                <a:ea typeface="Calibri" pitchFamily="34" charset="-122"/>
+                <a:cs typeface="Calibri" pitchFamily="34" charset="-120"/>
+              </a:rPr>
+              <a:t>주의 — 아키텍처 응집·일관성은 여전히 사람이 설계·책임져야 한다</a:t>
+            </a:r>
+            <a:endParaRPr lang="en-US" sz="1200" dirty="0"/>
+          </a:p>
+        </p:txBody>
+      </p:sp>
+      <p:sp>
+        <p:nvSpPr>
+          <p:cNvPr id="12" name="Shape 10"/>
+          <p:cNvSpPr/>
+          <p:nvPr/>
+        </p:nvSpPr>
+        <p:spPr>
+          <a:xfrm>
+            <a:off x="548640" y="3867912"/>
+            <a:ext cx="11091672" cy="932688"/>
+          </a:xfrm>
+          <a:prstGeom prst="rect">
+            <a:avLst/>
+          </a:prstGeom>
+          <a:solidFill>
+            <a:srgbClr val="161B22"/>
+          </a:solidFill>
+          <a:ln w="12700">
+            <a:solidFill>
+              <a:srgbClr val="30363D"/>
+            </a:solidFill>
+            <a:prstDash val="solid"/>
+          </a:ln>
+        </p:spPr>
+      </p:sp>
+      <p:sp>
+        <p:nvSpPr>
+          <p:cNvPr id="13" name="Shape 11"/>
+          <p:cNvSpPr/>
+          <p:nvPr/>
+        </p:nvSpPr>
+        <p:spPr>
+          <a:xfrm>
+            <a:off x="548640" y="3867912"/>
+            <a:ext cx="73152" cy="932688"/>
+          </a:xfrm>
+          <a:prstGeom prst="rect">
+            <a:avLst/>
+          </a:prstGeom>
+          <a:solidFill>
+            <a:srgbClr val="BC8CFF"/>
+          </a:solidFill>
+          <a:ln/>
+        </p:spPr>
+      </p:sp>
+      <p:sp>
+        <p:nvSpPr>
+          <p:cNvPr id="14" name="Text 12"/>
+          <p:cNvSpPr/>
+          <p:nvPr/>
+        </p:nvSpPr>
+        <p:spPr>
+          <a:xfrm>
+            <a:off x="868680" y="3959352"/>
+            <a:ext cx="2743200" cy="749808"/>
+          </a:xfrm>
+          <a:prstGeom prst="rect">
+            <a:avLst/>
+          </a:prstGeom>
+          <a:noFill/>
+          <a:ln/>
+        </p:spPr>
+        <p:txBody>
+          <a:bodyPr wrap="square" lIns="0" tIns="0" rIns="0" bIns="0" rtlCol="0" anchor="ctr"/>
+          <a:lstStyle/>
+          <a:p>
+            <a:pPr indent="0" marL="0">
+              <a:buNone/>
+            </a:pPr>
+            <a:r>
+              <a:rPr lang="en-US" sz="1500" b="1" dirty="0">
+                <a:solidFill>
+                  <a:srgbClr val="BC8CFF"/>
+                </a:solidFill>
+                <a:latin typeface="Calibri" pitchFamily="34" charset="0"/>
+                <a:ea typeface="Calibri" pitchFamily="34" charset="-122"/>
+                <a:cs typeface="Calibri" pitchFamily="34" charset="-120"/>
+              </a:rPr>
+              <a:t>통신 규율이 인프라</a:t>
+            </a:r>
+            <a:endParaRPr lang="en-US" sz="1500" dirty="0"/>
+          </a:p>
+        </p:txBody>
+      </p:sp>
+      <p:sp>
+        <p:nvSpPr>
+          <p:cNvPr id="15" name="Text 13"/>
+          <p:cNvSpPr/>
+          <p:nvPr/>
+        </p:nvSpPr>
+        <p:spPr>
+          <a:xfrm>
+            <a:off x="3749040" y="3959352"/>
+            <a:ext cx="7589520" cy="749808"/>
+          </a:xfrm>
+          <a:prstGeom prst="rect">
+            <a:avLst/>
+          </a:prstGeom>
+          <a:noFill/>
+          <a:ln/>
+        </p:spPr>
+        <p:txBody>
+          <a:bodyPr wrap="square" lIns="0" tIns="0" rIns="0" bIns="0" rtlCol="0" anchor="ctr"/>
+          <a:lstStyle/>
+          <a:p>
+            <a:pPr indent="0" marL="0">
+              <a:lnSpc>
+                <a:spcPct val="125000"/>
+              </a:lnSpc>
+              <a:spcAft>
+                <a:spcPts val="300"/>
+              </a:spcAft>
+              <a:buNone/>
+            </a:pPr>
+            <a:r>
+              <a:rPr lang="en-US" sz="1200" dirty="0">
+                <a:solidFill>
+                  <a:srgbClr val="E6EDF3"/>
+                </a:solidFill>
+                <a:latin typeface="Calibri" pitchFamily="34" charset="0"/>
+                <a:ea typeface="Calibri" pitchFamily="34" charset="-122"/>
+                <a:cs typeface="Calibri" pitchFamily="34" charset="-120"/>
+              </a:rPr>
+              <a:t>cmux·suf 같은 agent-to-agent 프로토콜과 cap discipline 이 생산성의 전제 조건이 된다</a:t>
+            </a:r>
+            <a:endParaRPr lang="en-US" sz="1200" dirty="0"/>
+          </a:p>
+          <a:p>
+            <a:pPr indent="0" marL="0">
+              <a:lnSpc>
+                <a:spcPct val="125000"/>
+              </a:lnSpc>
+              <a:spcAft>
+                <a:spcPts val="300"/>
+              </a:spcAft>
+              <a:buNone/>
+            </a:pPr>
+            <a:r>
+              <a:rPr lang="en-US" sz="1200" dirty="0">
+                <a:solidFill>
+                  <a:srgbClr val="D29922"/>
+                </a:solidFill>
+                <a:latin typeface="Calibri" pitchFamily="34" charset="0"/>
+                <a:ea typeface="Calibri" pitchFamily="34" charset="-122"/>
+                <a:cs typeface="Calibri" pitchFamily="34" charset="-120"/>
+              </a:rPr>
+              <a:t>주의 — 규율 없는 위임은 토큰·비용 폭주와 컨텍스트 단절로 직결</a:t>
+            </a:r>
+            <a:endParaRPr lang="en-US" sz="1200" dirty="0"/>
+          </a:p>
+        </p:txBody>
+      </p:sp>
+      <p:sp>
+        <p:nvSpPr>
+          <p:cNvPr id="16" name="Shape 14"/>
+          <p:cNvSpPr/>
+          <p:nvPr/>
+        </p:nvSpPr>
+        <p:spPr>
+          <a:xfrm>
+            <a:off x="548640" y="4910328"/>
+            <a:ext cx="11091672" cy="932688"/>
+          </a:xfrm>
+          <a:prstGeom prst="rect">
+            <a:avLst/>
+          </a:prstGeom>
+          <a:solidFill>
+            <a:srgbClr val="161B22"/>
+          </a:solidFill>
+          <a:ln w="12700">
+            <a:solidFill>
+              <a:srgbClr val="30363D"/>
+            </a:solidFill>
+            <a:prstDash val="solid"/>
+          </a:ln>
+        </p:spPr>
+      </p:sp>
+      <p:sp>
+        <p:nvSpPr>
+          <p:cNvPr id="17" name="Shape 15"/>
+          <p:cNvSpPr/>
+          <p:nvPr/>
+        </p:nvSpPr>
+        <p:spPr>
+          <a:xfrm>
+            <a:off x="548640" y="4910328"/>
+            <a:ext cx="73152" cy="932688"/>
+          </a:xfrm>
+          <a:prstGeom prst="rect">
+            <a:avLst/>
+          </a:prstGeom>
+          <a:solidFill>
+            <a:srgbClr val="D29922"/>
+          </a:solidFill>
+          <a:ln/>
+        </p:spPr>
+      </p:sp>
+      <p:sp>
+        <p:nvSpPr>
+          <p:cNvPr id="18" name="Text 16"/>
+          <p:cNvSpPr/>
+          <p:nvPr/>
+        </p:nvSpPr>
+        <p:spPr>
+          <a:xfrm>
+            <a:off x="868680" y="5001768"/>
+            <a:ext cx="2743200" cy="749808"/>
+          </a:xfrm>
+          <a:prstGeom prst="rect">
+            <a:avLst/>
+          </a:prstGeom>
+          <a:noFill/>
+          <a:ln/>
+        </p:spPr>
+        <p:txBody>
+          <a:bodyPr wrap="square" lIns="0" tIns="0" rIns="0" bIns="0" rtlCol="0" anchor="ctr"/>
+          <a:lstStyle/>
+          <a:p>
+            <a:pPr indent="0" marL="0">
+              <a:buNone/>
+            </a:pPr>
+            <a:r>
+              <a:rPr lang="en-US" sz="1500" b="1" dirty="0">
+                <a:solidFill>
+                  <a:srgbClr val="D29922"/>
+                </a:solidFill>
+                <a:latin typeface="Calibri" pitchFamily="34" charset="0"/>
+                <a:ea typeface="Calibri" pitchFamily="34" charset="-122"/>
+                <a:cs typeface="Calibri" pitchFamily="34" charset="-120"/>
+              </a:rPr>
+              <a:t>횡적 전문성의 재배치</a:t>
+            </a:r>
+            <a:endParaRPr lang="en-US" sz="1500" dirty="0"/>
+          </a:p>
+        </p:txBody>
+      </p:sp>
+      <p:sp>
+        <p:nvSpPr>
+          <p:cNvPr id="19" name="Text 17"/>
+          <p:cNvSpPr/>
+          <p:nvPr/>
+        </p:nvSpPr>
+        <p:spPr>
+          <a:xfrm>
+            <a:off x="3749040" y="5001768"/>
+            <a:ext cx="7589520" cy="749808"/>
+          </a:xfrm>
+          <a:prstGeom prst="rect">
+            <a:avLst/>
+          </a:prstGeom>
+          <a:noFill/>
+          <a:ln/>
+        </p:spPr>
+        <p:txBody>
+          <a:bodyPr wrap="square" lIns="0" tIns="0" rIns="0" bIns="0" rtlCol="0" anchor="ctr"/>
+          <a:lstStyle/>
+          <a:p>
+            <a:pPr indent="0" marL="0">
+              <a:lnSpc>
+                <a:spcPct val="125000"/>
+              </a:lnSpc>
+              <a:spcAft>
+                <a:spcPts val="300"/>
+              </a:spcAft>
+              <a:buNone/>
+            </a:pPr>
+            <a:r>
+              <a:rPr lang="en-US" sz="1200" dirty="0">
+                <a:solidFill>
+                  <a:srgbClr val="E6EDF3"/>
+                </a:solidFill>
+                <a:latin typeface="Calibri" pitchFamily="34" charset="0"/>
+                <a:ea typeface="Calibri" pitchFamily="34" charset="-122"/>
+                <a:cs typeface="Calibri" pitchFamily="34" charset="-120"/>
+              </a:rPr>
+              <a:t>보안·플랫폼·디자인시스템 등 공통 기반은 사라지지 않고 팀의 토대로 재배치된다</a:t>
+            </a:r>
+            <a:endParaRPr lang="en-US" sz="1200" dirty="0"/>
+          </a:p>
+          <a:p>
+            <a:pPr indent="0" marL="0">
+              <a:lnSpc>
+                <a:spcPct val="125000"/>
+              </a:lnSpc>
+              <a:spcAft>
+                <a:spcPts val="300"/>
+              </a:spcAft>
+              <a:buNone/>
+            </a:pPr>
+            <a:r>
+              <a:rPr lang="en-US" sz="1200" dirty="0">
+                <a:solidFill>
+                  <a:srgbClr val="D29922"/>
+                </a:solidFill>
+                <a:latin typeface="Calibri" pitchFamily="34" charset="0"/>
+                <a:ea typeface="Calibri" pitchFamily="34" charset="-122"/>
+                <a:cs typeface="Calibri" pitchFamily="34" charset="-120"/>
+              </a:rPr>
+              <a:t>주의 — 종적 전환은 '완전 대체'가 아니라 무게중심의 이동으로 봐야 한다</a:t>
+            </a:r>
+            <a:endParaRPr lang="en-US" sz="1200" dirty="0"/>
+          </a:p>
+        </p:txBody>
+      </p:sp>
+      <p:sp>
+        <p:nvSpPr>
+          <p:cNvPr id="20" name="Text 18"/>
+          <p:cNvSpPr/>
+          <p:nvPr/>
+        </p:nvSpPr>
+        <p:spPr>
+          <a:xfrm>
+            <a:off x="548640" y="6035040"/>
+            <a:ext cx="11091672" cy="457200"/>
+          </a:xfrm>
+          <a:prstGeom prst="rect">
+            <a:avLst/>
+          </a:prstGeom>
+          <a:noFill/>
+          <a:ln/>
+        </p:spPr>
+        <p:txBody>
+          <a:bodyPr wrap="square" lIns="0" tIns="0" rIns="0" bIns="0" rtlCol="0" anchor="ctr"/>
+          <a:lstStyle/>
+          <a:p>
+            <a:pPr indent="0" marL="0">
+              <a:buNone/>
+            </a:pPr>
+            <a:r>
+              <a:rPr lang="en-US" sz="1150" b="1" dirty="0">
+                <a:solidFill>
+                  <a:srgbClr val="3FB950"/>
+                </a:solidFill>
+                <a:latin typeface="Calibri" pitchFamily="34" charset="0"/>
+                <a:ea typeface="Calibri" pitchFamily="34" charset="-122"/>
+                <a:cs typeface="Calibri" pitchFamily="34" charset="-120"/>
+              </a:rPr>
+              <a:t>핵심  </a:t>
+            </a:r>
+            <a:pPr indent="0" marL="0">
+              <a:buNone/>
+            </a:pPr>
+            <a:r>
+              <a:rPr lang="en-US" sz="1150" dirty="0">
+                <a:solidFill>
+                  <a:srgbClr val="8B949E"/>
+                </a:solidFill>
+                <a:latin typeface="Calibri" pitchFamily="34" charset="0"/>
+                <a:ea typeface="Calibri" pitchFamily="34" charset="-122"/>
+                <a:cs typeface="Calibri" pitchFamily="34" charset="-120"/>
+              </a:rPr>
+              <a:t>'사람이 빠지는 것'이 아니라, 사람의 레버리지가 검증·설계·오케스트레이션으로 옮겨가는 변화다</a:t>
+            </a:r>
+            <a:endParaRPr lang="en-US" sz="1150" dirty="0"/>
+          </a:p>
+        </p:txBody>
+      </p:sp>
+    </p:spTree>
+  </p:cSld>
+  <p:clrMapOvr>
+    <a:masterClrMapping/>
+  </p:clrMapOvr>
+</p:sld>
+</file>
+
+<file path=ppt/slides/slide9.xml><?xml version="1.0" encoding="utf-8"?>
+<p:sld xmlns:a="http://schemas.openxmlformats.org/drawingml/2006/main" xmlns:r="http://schemas.openxmlformats.org/officeDocument/2006/relationships" xmlns:p="http://schemas.openxmlformats.org/presentationml/2006/main">
+  <p:cSld name="Slide 9">
+    <p:bg>
+      <p:bgPr>
+        <a:solidFill>
+          <a:srgbClr val="0D1117"/>
+        </a:solidFill>
+      </p:bgPr>
+    </p:bg>
+    <p:spTree>
+      <p:nvGrpSpPr>
+        <p:cNvPr id="1" name=""/>
+        <p:cNvGrpSpPr/>
+        <p:nvPr/>
+      </p:nvGrpSpPr>
+      <p:grpSpPr>
+        <a:xfrm>
+          <a:off x="0" y="0"/>
+          <a:ext cx="0" cy="0"/>
+          <a:chOff x="0" y="0"/>
+          <a:chExt cx="0" cy="0"/>
+        </a:xfrm>
+      </p:grpSpPr>
+      <p:sp>
+        <p:nvSpPr>
+          <p:cNvPr id="2" name="Shape 0"/>
+          <p:cNvSpPr/>
+          <p:nvPr/>
+        </p:nvSpPr>
+        <p:spPr>
+          <a:xfrm>
+            <a:off x="0" y="0"/>
+            <a:ext cx="109728" cy="6858000"/>
+          </a:xfrm>
+          <a:prstGeom prst="rect">
+            <a:avLst/>
+          </a:prstGeom>
+          <a:solidFill>
+            <a:srgbClr val="3FB950"/>
+          </a:solidFill>
+          <a:ln/>
+        </p:spPr>
+      </p:sp>
+      <p:sp>
+        <p:nvSpPr>
+          <p:cNvPr id="3" name="Text 1"/>
+          <p:cNvSpPr/>
+          <p:nvPr/>
+        </p:nvSpPr>
+        <p:spPr>
+          <a:xfrm>
+            <a:off x="822960" y="640080"/>
+            <a:ext cx="10515600" cy="365760"/>
+          </a:xfrm>
+          <a:prstGeom prst="rect">
+            <a:avLst/>
+          </a:prstGeom>
+          <a:noFill/>
+          <a:ln/>
+        </p:spPr>
+        <p:txBody>
+          <a:bodyPr wrap="square" lIns="0" tIns="0" rIns="0" bIns="0" rtlCol="0" anchor="ctr"/>
+          <a:lstStyle/>
+          <a:p>
+            <a:pPr indent="0" marL="0">
+              <a:buNone/>
+            </a:pPr>
+            <a:r>
+              <a:rPr lang="en-US" sz="1300" b="1" dirty="0">
+                <a:solidFill>
+                  <a:srgbClr val="3FB950"/>
+                </a:solidFill>
+                <a:latin typeface="Consolas" pitchFamily="34" charset="0"/>
+                <a:ea typeface="Consolas" pitchFamily="34" charset="-122"/>
+                <a:cs typeface="Consolas" pitchFamily="34" charset="-120"/>
+              </a:rPr>
+              <a:t>$ </a:t>
+            </a:r>
+            <a:pPr indent="0" marL="0">
+              <a:buNone/>
+            </a:pPr>
+            <a:r>
+              <a:rPr lang="en-US" sz="1300" dirty="0">
+                <a:solidFill>
+                  <a:srgbClr val="8B949E"/>
+                </a:solidFill>
+                <a:latin typeface="Consolas" pitchFamily="34" charset="0"/>
+                <a:ea typeface="Consolas" pitchFamily="34" charset="-122"/>
+                <a:cs typeface="Consolas" pitchFamily="34" charset="-120"/>
+              </a:rPr>
+              <a:t>cmux tree --all   # backend·frontend sidecar 확인</a:t>
+            </a:r>
+            <a:endParaRPr lang="en-US" sz="1300" dirty="0"/>
+          </a:p>
+        </p:txBody>
+      </p:sp>
+      <p:sp>
+        <p:nvSpPr>
+          <p:cNvPr id="4" name="Text 2"/>
+          <p:cNvSpPr/>
+          <p:nvPr/>
+        </p:nvSpPr>
+        <p:spPr>
+          <a:xfrm>
+            <a:off x="822960" y="1325880"/>
+            <a:ext cx="10515600" cy="868680"/>
+          </a:xfrm>
+          <a:prstGeom prst="rect">
+            <a:avLst/>
+          </a:prstGeom>
+          <a:noFill/>
+          <a:ln/>
+        </p:spPr>
+        <p:txBody>
+          <a:bodyPr wrap="square" lIns="0" tIns="0" rIns="0" bIns="0" rtlCol="0" anchor="ctr"/>
+          <a:lstStyle/>
+          <a:p>
+            <a:pPr indent="0" marL="0">
+              <a:buNone/>
+            </a:pPr>
+            <a:r>
+              <a:rPr lang="en-US" sz="4400" b="1" dirty="0">
+                <a:solidFill>
+                  <a:srgbClr val="E6EDF3"/>
+                </a:solidFill>
+                <a:latin typeface="Calibri" pitchFamily="34" charset="0"/>
+                <a:ea typeface="Calibri" pitchFamily="34" charset="-122"/>
+                <a:cs typeface="Calibri" pitchFamily="34" charset="-120"/>
+              </a:rPr>
+              <a:t>시연 </a:t>
+            </a:r>
+            <a:pPr indent="0" marL="0">
+              <a:buNone/>
+            </a:pPr>
+            <a:r>
+              <a:rPr lang="en-US" sz="4400" b="1" dirty="0">
+                <a:solidFill>
+                  <a:srgbClr val="3FB950"/>
+                </a:solidFill>
+                <a:latin typeface="Calibri" pitchFamily="34" charset="0"/>
+                <a:ea typeface="Calibri" pitchFamily="34" charset="-122"/>
+                <a:cs typeface="Calibri" pitchFamily="34" charset="-120"/>
+              </a:rPr>
+              <a:t>· Live Demo</a:t>
+            </a:r>
+            <a:endParaRPr lang="en-US" sz="4400" dirty="0"/>
+          </a:p>
+        </p:txBody>
+      </p:sp>
+      <p:sp>
+        <p:nvSpPr>
+          <p:cNvPr id="5" name="Text 3"/>
+          <p:cNvSpPr/>
+          <p:nvPr/>
+        </p:nvSpPr>
+        <p:spPr>
+          <a:xfrm>
+            <a:off x="841248" y="2286000"/>
+            <a:ext cx="10515600" cy="411480"/>
+          </a:xfrm>
+          <a:prstGeom prst="rect">
+            <a:avLst/>
+          </a:prstGeom>
+          <a:noFill/>
+          <a:ln/>
+        </p:spPr>
+        <p:txBody>
+          <a:bodyPr wrap="square" lIns="0" tIns="0" rIns="0" bIns="0" rtlCol="0" anchor="ctr"/>
+          <a:lstStyle/>
+          <a:p>
+            <a:pPr indent="0" marL="0">
+              <a:buNone/>
+            </a:pPr>
+            <a:r>
+              <a:rPr lang="en-US" sz="1400" dirty="0">
+                <a:solidFill>
+                  <a:srgbClr val="58A6FF"/>
+                </a:solidFill>
+                <a:latin typeface="Consolas" pitchFamily="34" charset="0"/>
+                <a:ea typeface="Consolas" pitchFamily="34" charset="-122"/>
+                <a:cs typeface="Consolas" pitchFamily="34" charset="-120"/>
+              </a:rPr>
+              <a:t>발표자가 직접 진행합니다 — codex · claude · pi 의 실시간 협업</a:t>
+            </a:r>
+            <a:endParaRPr lang="en-US" sz="1400" dirty="0"/>
+          </a:p>
+        </p:txBody>
+      </p:sp>
+      <p:sp>
+        <p:nvSpPr>
+          <p:cNvPr id="6" name="Shape 4"/>
+          <p:cNvSpPr/>
+          <p:nvPr/>
+        </p:nvSpPr>
+        <p:spPr>
+          <a:xfrm>
+            <a:off x="822960" y="2880360"/>
+            <a:ext cx="6629400" cy="3063240"/>
+          </a:xfrm>
+          <a:prstGeom prst="rect">
+            <a:avLst/>
+          </a:prstGeom>
+          <a:solidFill>
+            <a:srgbClr val="161B22"/>
+          </a:solidFill>
+          <a:ln w="19050">
+            <a:solidFill>
+              <a:srgbClr val="3FB950"/>
+            </a:solidFill>
+            <a:prstDash val="solid"/>
+          </a:ln>
+        </p:spPr>
+      </p:sp>
+      <p:sp>
+        <p:nvSpPr>
+          <p:cNvPr id="7" name="Shape 5"/>
+          <p:cNvSpPr/>
+          <p:nvPr/>
+        </p:nvSpPr>
+        <p:spPr>
+          <a:xfrm>
+            <a:off x="822960" y="2880360"/>
+            <a:ext cx="6629400" cy="384048"/>
+          </a:xfrm>
+          <a:prstGeom prst="rect">
+            <a:avLst/>
+          </a:prstGeom>
+          <a:solidFill>
+            <a:srgbClr val="1C2128"/>
+          </a:solidFill>
+          <a:ln/>
+        </p:spPr>
+      </p:sp>
+      <p:sp>
+        <p:nvSpPr>
+          <p:cNvPr id="8" name="Shape 6"/>
+          <p:cNvSpPr/>
+          <p:nvPr/>
+        </p:nvSpPr>
+        <p:spPr>
+          <a:xfrm>
+            <a:off x="987552" y="3017520"/>
+            <a:ext cx="118872" cy="118872"/>
+          </a:xfrm>
+          <a:prstGeom prst="ellipse">
+            <a:avLst/>
+          </a:prstGeom>
+          <a:solidFill>
+            <a:srgbClr val="F85149"/>
+          </a:solidFill>
+          <a:ln/>
+        </p:spPr>
+      </p:sp>
+      <p:sp>
+        <p:nvSpPr>
+          <p:cNvPr id="9" name="Shape 7"/>
+          <p:cNvSpPr/>
+          <p:nvPr/>
+        </p:nvSpPr>
+        <p:spPr>
+          <a:xfrm>
+            <a:off x="1188720" y="3017520"/>
+            <a:ext cx="118872" cy="118872"/>
+          </a:xfrm>
+          <a:prstGeom prst="ellipse">
+            <a:avLst/>
+          </a:prstGeom>
+          <a:solidFill>
+            <a:srgbClr val="D29922"/>
+          </a:solidFill>
+          <a:ln/>
+        </p:spPr>
+      </p:sp>
+      <p:sp>
+        <p:nvSpPr>
+          <p:cNvPr id="10" name="Shape 8"/>
+          <p:cNvSpPr/>
+          <p:nvPr/>
+        </p:nvSpPr>
+        <p:spPr>
+          <a:xfrm>
+            <a:off x="1389888" y="3017520"/>
+            <a:ext cx="118872" cy="118872"/>
+          </a:xfrm>
+          <a:prstGeom prst="ellipse">
+            <a:avLst/>
+          </a:prstGeom>
+          <a:solidFill>
+            <a:srgbClr val="3FB950"/>
+          </a:solidFill>
+          <a:ln/>
+        </p:spPr>
+      </p:sp>
+      <p:sp>
+        <p:nvSpPr>
+          <p:cNvPr id="11" name="Text 9"/>
+          <p:cNvSpPr/>
+          <p:nvPr/>
+        </p:nvSpPr>
+        <p:spPr>
+          <a:xfrm>
+            <a:off x="1691640" y="2880360"/>
+            <a:ext cx="5623560" cy="384048"/>
+          </a:xfrm>
+          <a:prstGeom prst="rect">
+            <a:avLst/>
+          </a:prstGeom>
+          <a:noFill/>
+          <a:ln/>
+        </p:spPr>
+        <p:txBody>
+          <a:bodyPr wrap="square" lIns="0" tIns="0" rIns="0" bIns="0" rtlCol="0" anchor="ctr"/>
+          <a:lstStyle/>
+          <a:p>
+            <a:pPr algn="l" indent="0" marL="0">
+              <a:buNone/>
+            </a:pPr>
+            <a:r>
+              <a:rPr lang="en-US" sz="1100" dirty="0">
+                <a:solidFill>
+                  <a:srgbClr val="8B949E"/>
+                </a:solidFill>
+                <a:latin typeface="Consolas" pitchFamily="34" charset="0"/>
+                <a:ea typeface="Consolas" pitchFamily="34" charset="-122"/>
+                <a:cs typeface="Consolas" pitchFamily="34" charset="-120"/>
+              </a:rPr>
+              <a:t>orchestrator — workspace:1</a:t>
+            </a:r>
+            <a:endParaRPr lang="en-US" sz="1100" dirty="0"/>
+          </a:p>
+        </p:txBody>
+      </p:sp>
+      <p:sp>
+        <p:nvSpPr>
+          <p:cNvPr id="12" name="Shape 10"/>
+          <p:cNvSpPr/>
+          <p:nvPr/>
+        </p:nvSpPr>
+        <p:spPr>
+          <a:xfrm>
+            <a:off x="1024128" y="3429000"/>
+            <a:ext cx="6217920" cy="2395728"/>
+          </a:xfrm>
+          <a:prstGeom prst="rect">
+            <a:avLst/>
+          </a:prstGeom>
+          <a:solidFill>
+            <a:srgbClr val="010409"/>
+          </a:solidFill>
+          <a:ln w="12700">
+            <a:solidFill>
+              <a:srgbClr val="30363D"/>
+            </a:solidFill>
+            <a:prstDash val="solid"/>
+          </a:ln>
+        </p:spPr>
+      </p:sp>
+      <p:sp>
+        <p:nvSpPr>
+          <p:cNvPr id="13" name="Text 11"/>
+          <p:cNvSpPr/>
+          <p:nvPr/>
+        </p:nvSpPr>
+        <p:spPr>
+          <a:xfrm>
+            <a:off x="1207008" y="3566160"/>
+            <a:ext cx="5852160" cy="2121408"/>
+          </a:xfrm>
+          <a:prstGeom prst="rect">
+            <a:avLst/>
+          </a:prstGeom>
+          <a:noFill/>
+          <a:ln/>
+        </p:spPr>
+        <p:txBody>
+          <a:bodyPr wrap="square" lIns="0" tIns="0" rIns="0" bIns="0" rtlCol="0" anchor="t"/>
+          <a:lstStyle/>
+          <a:p>
+            <a:pPr algn="l" indent="0" marL="0">
+              <a:lnSpc>
+                <a:spcPct val="118000"/>
+              </a:lnSpc>
+              <a:buNone/>
+            </a:pPr>
+            <a:r>
+              <a:rPr lang="en-US" sz="1100" dirty="0">
+                <a:solidFill>
+                  <a:srgbClr val="8B949E"/>
+                </a:solidFill>
+                <a:latin typeface="Consolas" pitchFamily="34" charset="0"/>
+                <a:ea typeface="Consolas" pitchFamily="34" charset="-122"/>
+                <a:cs typeface="Consolas" pitchFamily="34" charset="-120"/>
+              </a:rPr>
+              <a:t>source ~/.agents/skills/suf/scripts/suf-v5-lib.sh</a:t>
+            </a:r>
+            <a:endParaRPr lang="en-US" sz="1100" dirty="0"/>
+          </a:p>
+          <a:p>
+            <a:pPr algn="l" indent="0" marL="0">
+              <a:lnSpc>
+                <a:spcPct val="118000"/>
+              </a:lnSpc>
+              <a:buNone/>
+            </a:pPr>
+            <a:endParaRPr lang="en-US" sz="1100" dirty="0"/>
+          </a:p>
+          <a:p>
+            <a:pPr algn="l" indent="0" marL="0">
+              <a:lnSpc>
+                <a:spcPct val="118000"/>
+              </a:lnSpc>
+              <a:buNone/>
+            </a:pPr>
+            <a:r>
+              <a:rPr lang="en-US" sz="1100" dirty="0">
+                <a:solidFill>
+                  <a:srgbClr val="E6EDF3"/>
+                </a:solidFill>
+                <a:latin typeface="Consolas" pitchFamily="34" charset="0"/>
+                <a:ea typeface="Consolas" pitchFamily="34" charset="-122"/>
+                <a:cs typeface="Consolas" pitchFamily="34" charset="-120"/>
+              </a:rPr>
+              <a:t>b=$(</a:t>
+            </a:r>
+            <a:pPr algn="l" indent="0" marL="0">
+              <a:lnSpc>
+                <a:spcPct val="118000"/>
+              </a:lnSpc>
+              <a:buNone/>
+            </a:pPr>
+            <a:r>
+              <a:rPr lang="en-US" sz="1100" dirty="0">
+                <a:solidFill>
+                  <a:srgbClr val="3FB950"/>
+                </a:solidFill>
+                <a:latin typeface="Consolas" pitchFamily="34" charset="0"/>
+                <a:ea typeface="Consolas" pitchFamily="34" charset="-122"/>
+                <a:cs typeface="Consolas" pitchFamily="34" charset="-120"/>
+              </a:rPr>
+              <a:t>suf_by_title backend</a:t>
+            </a:r>
+            <a:pPr algn="l" indent="0" marL="0">
+              <a:lnSpc>
+                <a:spcPct val="118000"/>
+              </a:lnSpc>
+              <a:buNone/>
+            </a:pPr>
+            <a:r>
+              <a:rPr lang="en-US" sz="1100" dirty="0">
+                <a:solidFill>
+                  <a:srgbClr val="E6EDF3"/>
+                </a:solidFill>
+                <a:latin typeface="Consolas" pitchFamily="34" charset="0"/>
+                <a:ea typeface="Consolas" pitchFamily="34" charset="-122"/>
+                <a:cs typeface="Consolas" pitchFamily="34" charset="-120"/>
+              </a:rPr>
+              <a:t> \</a:t>
+            </a:r>
+            <a:endParaRPr lang="en-US" sz="1100" dirty="0"/>
+          </a:p>
+          <a:p>
+            <a:pPr algn="l" indent="0" marL="0">
+              <a:lnSpc>
+                <a:spcPct val="118000"/>
+              </a:lnSpc>
+              <a:buNone/>
+            </a:pPr>
+            <a:r>
+              <a:rPr lang="en-US" sz="1100" dirty="0">
+                <a:solidFill>
+                  <a:srgbClr val="E6EDF3"/>
+                </a:solidFill>
+                <a:latin typeface="Consolas" pitchFamily="34" charset="0"/>
+                <a:ea typeface="Consolas" pitchFamily="34" charset="-122"/>
+                <a:cs typeface="Consolas" pitchFamily="34" charset="-120"/>
+              </a:rPr>
+              <a:t>      "GET /users 응답 스키마 한 줄")</a:t>
+            </a:r>
+            <a:endParaRPr lang="en-US" sz="1100" dirty="0"/>
+          </a:p>
+          <a:p>
+            <a:pPr algn="l" indent="0" marL="0">
+              <a:lnSpc>
+                <a:spcPct val="118000"/>
+              </a:lnSpc>
+              <a:buNone/>
+            </a:pPr>
+            <a:r>
+              <a:rPr lang="en-US" sz="1100" dirty="0">
+                <a:solidFill>
+                  <a:srgbClr val="E6EDF3"/>
+                </a:solidFill>
+                <a:latin typeface="Consolas" pitchFamily="34" charset="0"/>
+                <a:ea typeface="Consolas" pitchFamily="34" charset="-122"/>
+                <a:cs typeface="Consolas" pitchFamily="34" charset="-120"/>
+              </a:rPr>
+              <a:t>f=$(</a:t>
+            </a:r>
+            <a:pPr algn="l" indent="0" marL="0">
+              <a:lnSpc>
+                <a:spcPct val="118000"/>
+              </a:lnSpc>
+              <a:buNone/>
+            </a:pPr>
+            <a:r>
+              <a:rPr lang="en-US" sz="1100" dirty="0">
+                <a:solidFill>
+                  <a:srgbClr val="BC8CFF"/>
+                </a:solidFill>
+                <a:latin typeface="Consolas" pitchFamily="34" charset="0"/>
+                <a:ea typeface="Consolas" pitchFamily="34" charset="-122"/>
+                <a:cs typeface="Consolas" pitchFamily="34" charset="-120"/>
+              </a:rPr>
+              <a:t>suf_by_title frontend</a:t>
+            </a:r>
+            <a:pPr algn="l" indent="0" marL="0">
+              <a:lnSpc>
+                <a:spcPct val="118000"/>
+              </a:lnSpc>
+              <a:buNone/>
+            </a:pPr>
+            <a:r>
+              <a:rPr lang="en-US" sz="1100" dirty="0">
+                <a:solidFill>
+                  <a:srgbClr val="E6EDF3"/>
+                </a:solidFill>
+                <a:latin typeface="Consolas" pitchFamily="34" charset="0"/>
+                <a:ea typeface="Consolas" pitchFamily="34" charset="-122"/>
+                <a:cs typeface="Consolas" pitchFamily="34" charset="-120"/>
+              </a:rPr>
+              <a:t> \</a:t>
+            </a:r>
+            <a:endParaRPr lang="en-US" sz="1100" dirty="0"/>
+          </a:p>
+          <a:p>
+            <a:pPr algn="l" indent="0" marL="0">
+              <a:lnSpc>
+                <a:spcPct val="118000"/>
+              </a:lnSpc>
+              <a:buNone/>
+            </a:pPr>
+            <a:r>
+              <a:rPr lang="en-US" sz="1100" dirty="0">
+                <a:solidFill>
+                  <a:srgbClr val="E6EDF3"/>
+                </a:solidFill>
+                <a:latin typeface="Consolas" pitchFamily="34" charset="0"/>
+                <a:ea typeface="Consolas" pitchFamily="34" charset="-122"/>
+                <a:cs typeface="Consolas" pitchFamily="34" charset="-120"/>
+              </a:rPr>
+              <a:t>      "위 스키마로 fetch 타입 한 줄: $b")</a:t>
+            </a:r>
+            <a:endParaRPr lang="en-US" sz="1100" dirty="0"/>
+          </a:p>
+          <a:p>
+            <a:pPr algn="l" indent="0" marL="0">
+              <a:lnSpc>
+                <a:spcPct val="118000"/>
+              </a:lnSpc>
+              <a:buNone/>
+            </a:pPr>
+            <a:endParaRPr lang="en-US" sz="1100" dirty="0"/>
+          </a:p>
+          <a:p>
+            <a:pPr algn="l" indent="0" marL="0">
+              <a:lnSpc>
+                <a:spcPct val="118000"/>
+              </a:lnSpc>
+              <a:buNone/>
+            </a:pPr>
+            <a:r>
+              <a:rPr lang="en-US" sz="1100" dirty="0">
+                <a:solidFill>
+                  <a:srgbClr val="58A6FF"/>
+                </a:solidFill>
+                <a:latin typeface="Consolas" pitchFamily="34" charset="0"/>
+                <a:ea typeface="Consolas" pitchFamily="34" charset="-122"/>
+                <a:cs typeface="Consolas" pitchFamily="34" charset="-120"/>
+              </a:rPr>
+              <a:t>echo "$b"; echo "$f"</a:t>
+            </a:r>
+            <a:endParaRPr lang="en-US" sz="1100" dirty="0"/>
+          </a:p>
+        </p:txBody>
+      </p:sp>
+      <p:sp>
+        <p:nvSpPr>
+          <p:cNvPr id="14" name="Text 12"/>
+          <p:cNvSpPr/>
+          <p:nvPr/>
+        </p:nvSpPr>
+        <p:spPr>
+          <a:xfrm>
+            <a:off x="7726680" y="2880360"/>
+            <a:ext cx="3657600" cy="320040"/>
+          </a:xfrm>
+          <a:prstGeom prst="rect">
+            <a:avLst/>
+          </a:prstGeom>
+          <a:noFill/>
+          <a:ln/>
+        </p:spPr>
+        <p:txBody>
+          <a:bodyPr wrap="square" lIns="0" tIns="0" rIns="0" bIns="0" rtlCol="0" anchor="ctr"/>
+          <a:lstStyle/>
+          <a:p>
+            <a:pPr indent="0" marL="0">
+              <a:buNone/>
+            </a:pPr>
+            <a:r>
+              <a:rPr lang="en-US" sz="1300" b="1" dirty="0">
+                <a:solidFill>
+                  <a:srgbClr val="8B949E"/>
+                </a:solidFill>
+                <a:latin typeface="Calibri" pitchFamily="34" charset="0"/>
+                <a:ea typeface="Calibri" pitchFamily="34" charset="-122"/>
+                <a:cs typeface="Calibri" pitchFamily="34" charset="-120"/>
+              </a:rPr>
+              <a:t>시연 시나리오</a:t>
+            </a:r>
+            <a:endParaRPr lang="en-US" sz="1300" dirty="0"/>
+          </a:p>
+        </p:txBody>
+      </p:sp>
+      <p:sp>
+        <p:nvSpPr>
+          <p:cNvPr id="15" name="Shape 13"/>
+          <p:cNvSpPr/>
+          <p:nvPr/>
+        </p:nvSpPr>
+        <p:spPr>
+          <a:xfrm>
+            <a:off x="7726680" y="3291840"/>
+            <a:ext cx="3639312" cy="749808"/>
+          </a:xfrm>
+          <a:prstGeom prst="rect">
+            <a:avLst/>
+          </a:prstGeom>
+          <a:solidFill>
+            <a:srgbClr val="161B22"/>
+          </a:solidFill>
+          <a:ln w="19050">
+            <a:solidFill>
+              <a:srgbClr val="3FB950"/>
+            </a:solidFill>
+            <a:prstDash val="solid"/>
+          </a:ln>
+        </p:spPr>
+      </p:sp>
+      <p:sp>
+        <p:nvSpPr>
+          <p:cNvPr id="16" name="Shape 14"/>
+          <p:cNvSpPr/>
+          <p:nvPr/>
+        </p:nvSpPr>
+        <p:spPr>
+          <a:xfrm>
+            <a:off x="7909560" y="3511296"/>
+            <a:ext cx="329184" cy="329184"/>
+          </a:xfrm>
+          <a:prstGeom prst="ellipse">
+            <a:avLst/>
+          </a:prstGeom>
+          <a:solidFill>
+            <a:srgbClr val="3FB950"/>
+          </a:solidFill>
+          <a:ln/>
+        </p:spPr>
+      </p:sp>
+      <p:sp>
+        <p:nvSpPr>
+          <p:cNvPr id="17" name="Text 15"/>
+          <p:cNvSpPr/>
+          <p:nvPr/>
+        </p:nvSpPr>
+        <p:spPr>
+          <a:xfrm>
+            <a:off x="7909560" y="3511296"/>
+            <a:ext cx="329184" cy="329184"/>
+          </a:xfrm>
+          <a:prstGeom prst="rect">
+            <a:avLst/>
+          </a:prstGeom>
+          <a:noFill/>
+          <a:ln/>
+        </p:spPr>
+        <p:txBody>
+          <a:bodyPr wrap="square" lIns="0" tIns="0" rIns="0" bIns="0" rtlCol="0" anchor="ctr"/>
+          <a:lstStyle/>
+          <a:p>
+            <a:pPr algn="ctr" indent="0" marL="0">
+              <a:buNone/>
+            </a:pPr>
+            <a:r>
+              <a:rPr lang="en-US" sz="1400" b="1" dirty="0">
+                <a:solidFill>
+                  <a:srgbClr val="0D1117"/>
+                </a:solidFill>
+                <a:latin typeface="Consolas" pitchFamily="34" charset="0"/>
+                <a:ea typeface="Consolas" pitchFamily="34" charset="-122"/>
+                <a:cs typeface="Consolas" pitchFamily="34" charset="-120"/>
+              </a:rPr>
+              <a:t>1</a:t>
+            </a:r>
+            <a:endParaRPr lang="en-US" sz="1400" dirty="0"/>
+          </a:p>
+        </p:txBody>
+      </p:sp>
+      <p:sp>
+        <p:nvSpPr>
+          <p:cNvPr id="18" name="Text 16"/>
+          <p:cNvSpPr/>
+          <p:nvPr/>
+        </p:nvSpPr>
+        <p:spPr>
+          <a:xfrm>
+            <a:off x="8412480" y="3291840"/>
+            <a:ext cx="2834640" cy="749808"/>
+          </a:xfrm>
+          <a:prstGeom prst="rect">
+            <a:avLst/>
+          </a:prstGeom>
+          <a:noFill/>
+          <a:ln/>
+        </p:spPr>
+        <p:txBody>
+          <a:bodyPr wrap="square" lIns="0" tIns="0" rIns="0" bIns="0" rtlCol="0" anchor="ctr"/>
+          <a:lstStyle/>
+          <a:p>
+            <a:pPr indent="0" marL="0">
+              <a:buNone/>
+            </a:pPr>
+            <a:r>
+              <a:rPr lang="en-US" sz="1200" dirty="0">
+                <a:solidFill>
+                  <a:srgbClr val="E6EDF3"/>
+                </a:solidFill>
+                <a:latin typeface="Calibri" pitchFamily="34" charset="0"/>
+                <a:ea typeface="Calibri" pitchFamily="34" charset="-122"/>
+                <a:cs typeface="Calibri" pitchFamily="34" charset="-120"/>
+              </a:rPr>
+              <a:t>backend(claude) 에 API 계약 질의</a:t>
+            </a:r>
+            <a:endParaRPr lang="en-US" sz="1200" dirty="0"/>
+          </a:p>
+        </p:txBody>
+      </p:sp>
+      <p:sp>
+        <p:nvSpPr>
+          <p:cNvPr id="19" name="Shape 17"/>
+          <p:cNvSpPr/>
+          <p:nvPr/>
+        </p:nvSpPr>
+        <p:spPr>
+          <a:xfrm>
+            <a:off x="7726680" y="4178808"/>
+            <a:ext cx="3639312" cy="749808"/>
+          </a:xfrm>
+          <a:prstGeom prst="rect">
+            <a:avLst/>
+          </a:prstGeom>
+          <a:solidFill>
+            <a:srgbClr val="161B22"/>
+          </a:solidFill>
+          <a:ln w="19050">
+            <a:solidFill>
+              <a:srgbClr val="BC8CFF"/>
+            </a:solidFill>
+            <a:prstDash val="solid"/>
+          </a:ln>
+        </p:spPr>
+      </p:sp>
+      <p:sp>
+        <p:nvSpPr>
+          <p:cNvPr id="20" name="Shape 18"/>
+          <p:cNvSpPr/>
+          <p:nvPr/>
+        </p:nvSpPr>
+        <p:spPr>
+          <a:xfrm>
+            <a:off x="7909560" y="4398264"/>
+            <a:ext cx="329184" cy="329184"/>
+          </a:xfrm>
+          <a:prstGeom prst="ellipse">
+            <a:avLst/>
+          </a:prstGeom>
+          <a:solidFill>
+            <a:srgbClr val="BC8CFF"/>
+          </a:solidFill>
+          <a:ln/>
+        </p:spPr>
+      </p:sp>
+      <p:sp>
+        <p:nvSpPr>
+          <p:cNvPr id="21" name="Text 19"/>
+          <p:cNvSpPr/>
+          <p:nvPr/>
+        </p:nvSpPr>
+        <p:spPr>
+          <a:xfrm>
+            <a:off x="7909560" y="4398264"/>
+            <a:ext cx="329184" cy="329184"/>
+          </a:xfrm>
+          <a:prstGeom prst="rect">
+            <a:avLst/>
+          </a:prstGeom>
+          <a:noFill/>
+          <a:ln/>
+        </p:spPr>
+        <p:txBody>
+          <a:bodyPr wrap="square" lIns="0" tIns="0" rIns="0" bIns="0" rtlCol="0" anchor="ctr"/>
+          <a:lstStyle/>
+          <a:p>
+            <a:pPr algn="ctr" indent="0" marL="0">
+              <a:buNone/>
+            </a:pPr>
+            <a:r>
+              <a:rPr lang="en-US" sz="1400" b="1" dirty="0">
+                <a:solidFill>
+                  <a:srgbClr val="0D1117"/>
+                </a:solidFill>
+                <a:latin typeface="Consolas" pitchFamily="34" charset="0"/>
+                <a:ea typeface="Consolas" pitchFamily="34" charset="-122"/>
+                <a:cs typeface="Consolas" pitchFamily="34" charset="-120"/>
+              </a:rPr>
+              <a:t>2</a:t>
+            </a:r>
+            <a:endParaRPr lang="en-US" sz="1400" dirty="0"/>
+          </a:p>
+        </p:txBody>
+      </p:sp>
+      <p:sp>
+        <p:nvSpPr>
+          <p:cNvPr id="22" name="Text 20"/>
+          <p:cNvSpPr/>
+          <p:nvPr/>
+        </p:nvSpPr>
+        <p:spPr>
+          <a:xfrm>
+            <a:off x="8412480" y="4178808"/>
+            <a:ext cx="2834640" cy="749808"/>
+          </a:xfrm>
+          <a:prstGeom prst="rect">
+            <a:avLst/>
+          </a:prstGeom>
+          <a:noFill/>
+          <a:ln/>
+        </p:spPr>
+        <p:txBody>
+          <a:bodyPr wrap="square" lIns="0" tIns="0" rIns="0" bIns="0" rtlCol="0" anchor="ctr"/>
+          <a:lstStyle/>
+          <a:p>
+            <a:pPr indent="0" marL="0">
+              <a:buNone/>
+            </a:pPr>
+            <a:r>
+              <a:rPr lang="en-US" sz="1200" dirty="0">
+                <a:solidFill>
+                  <a:srgbClr val="E6EDF3"/>
+                </a:solidFill>
+                <a:latin typeface="Calibri" pitchFamily="34" charset="0"/>
+                <a:ea typeface="Calibri" pitchFamily="34" charset="-122"/>
+                <a:cs typeface="Calibri" pitchFamily="34" charset="-120"/>
+              </a:rPr>
+              <a:t>frontend(pi) 에 타입 생성 위임</a:t>
+            </a:r>
+            <a:endParaRPr lang="en-US" sz="1200" dirty="0"/>
+          </a:p>
+        </p:txBody>
+      </p:sp>
+      <p:sp>
+        <p:nvSpPr>
+          <p:cNvPr id="23" name="Shape 21"/>
+          <p:cNvSpPr/>
+          <p:nvPr/>
+        </p:nvSpPr>
+        <p:spPr>
+          <a:xfrm>
+            <a:off x="7726680" y="5065776"/>
+            <a:ext cx="3639312" cy="749808"/>
+          </a:xfrm>
+          <a:prstGeom prst="rect">
+            <a:avLst/>
+          </a:prstGeom>
+          <a:solidFill>
+            <a:srgbClr val="161B22"/>
+          </a:solidFill>
+          <a:ln w="19050">
+            <a:solidFill>
+              <a:srgbClr val="58A6FF"/>
+            </a:solidFill>
+            <a:prstDash val="solid"/>
+          </a:ln>
+        </p:spPr>
+      </p:sp>
+      <p:sp>
+        <p:nvSpPr>
+          <p:cNvPr id="24" name="Shape 22"/>
+          <p:cNvSpPr/>
+          <p:nvPr/>
+        </p:nvSpPr>
+        <p:spPr>
+          <a:xfrm>
+            <a:off x="7909560" y="5285232"/>
+            <a:ext cx="329184" cy="329184"/>
+          </a:xfrm>
+          <a:prstGeom prst="ellipse">
+            <a:avLst/>
+          </a:prstGeom>
+          <a:solidFill>
+            <a:srgbClr val="58A6FF"/>
+          </a:solidFill>
+          <a:ln/>
+        </p:spPr>
+      </p:sp>
+      <p:sp>
+        <p:nvSpPr>
+          <p:cNvPr id="25" name="Text 23"/>
+          <p:cNvSpPr/>
+          <p:nvPr/>
+        </p:nvSpPr>
+        <p:spPr>
+          <a:xfrm>
+            <a:off x="7909560" y="5285232"/>
+            <a:ext cx="329184" cy="329184"/>
+          </a:xfrm>
+          <a:prstGeom prst="rect">
+            <a:avLst/>
+          </a:prstGeom>
+          <a:noFill/>
+          <a:ln/>
+        </p:spPr>
+        <p:txBody>
+          <a:bodyPr wrap="square" lIns="0" tIns="0" rIns="0" bIns="0" rtlCol="0" anchor="ctr"/>
+          <a:lstStyle/>
+          <a:p>
+            <a:pPr algn="ctr" indent="0" marL="0">
+              <a:buNone/>
+            </a:pPr>
+            <a:r>
+              <a:rPr lang="en-US" sz="1400" b="1" dirty="0">
+                <a:solidFill>
+                  <a:srgbClr val="0D1117"/>
+                </a:solidFill>
+                <a:latin typeface="Consolas" pitchFamily="34" charset="0"/>
+                <a:ea typeface="Consolas" pitchFamily="34" charset="-122"/>
+                <a:cs typeface="Consolas" pitchFamily="34" charset="-120"/>
+              </a:rPr>
+              <a:t>3</a:t>
+            </a:r>
+            <a:endParaRPr lang="en-US" sz="1400" dirty="0"/>
+          </a:p>
+        </p:txBody>
+      </p:sp>
+      <p:sp>
+        <p:nvSpPr>
+          <p:cNvPr id="26" name="Text 24"/>
+          <p:cNvSpPr/>
+          <p:nvPr/>
+        </p:nvSpPr>
+        <p:spPr>
+          <a:xfrm>
+            <a:off x="8412480" y="5065776"/>
+            <a:ext cx="2834640" cy="749808"/>
+          </a:xfrm>
+          <a:prstGeom prst="rect">
+            <a:avLst/>
+          </a:prstGeom>
+          <a:noFill/>
+          <a:ln/>
+        </p:spPr>
+        <p:txBody>
+          <a:bodyPr wrap="square" lIns="0" tIns="0" rIns="0" bIns="0" rtlCol="0" anchor="ctr"/>
+          <a:lstStyle/>
+          <a:p>
+            <a:pPr indent="0" marL="0">
+              <a:buNone/>
+            </a:pPr>
+            <a:r>
+              <a:rPr lang="en-US" sz="1200" dirty="0">
+                <a:solidFill>
+                  <a:srgbClr val="E6EDF3"/>
+                </a:solidFill>
+                <a:latin typeface="Calibri" pitchFamily="34" charset="0"/>
+                <a:ea typeface="Calibri" pitchFamily="34" charset="-122"/>
+                <a:cs typeface="Calibri" pitchFamily="34" charset="-120"/>
+              </a:rPr>
+              <a:t>두 응답 종합 — 실시간 협업 확인</a:t>
+            </a:r>
+            <a:endParaRPr lang="en-US" sz="1200" dirty="0"/>
+          </a:p>
+        </p:txBody>
+      </p:sp>
+      <p:sp>
+        <p:nvSpPr>
+          <p:cNvPr id="27" name="Text 25"/>
+          <p:cNvSpPr/>
+          <p:nvPr/>
+        </p:nvSpPr>
+        <p:spPr>
+          <a:xfrm>
+            <a:off x="841248" y="6263640"/>
+            <a:ext cx="10515600" cy="365760"/>
+          </a:xfrm>
+          <a:prstGeom prst="rect">
+            <a:avLst/>
+          </a:prstGeom>
+          <a:noFill/>
+          <a:ln/>
+        </p:spPr>
+        <p:txBody>
+          <a:bodyPr wrap="square" lIns="0" tIns="0" rIns="0" bIns="0" rtlCol="0" anchor="ctr"/>
+          <a:lstStyle/>
+          <a:p>
+            <a:pPr indent="0" marL="0">
+              <a:buNone/>
+            </a:pPr>
+            <a:r>
+              <a:rPr lang="en-US" sz="1300" dirty="0">
+                <a:solidFill>
+                  <a:srgbClr val="3FB950"/>
+                </a:solidFill>
+                <a:latin typeface="Consolas" pitchFamily="34" charset="0"/>
+                <a:ea typeface="Consolas" pitchFamily="34" charset="-122"/>
+                <a:cs typeface="Consolas" pitchFamily="34" charset="-120"/>
+              </a:rPr>
+              <a:t>▶  지금부터 화면으로 직접 보여드립니다</a:t>
+            </a:r>
+            <a:endParaRPr lang="en-US" sz="1300" dirty="0"/>
           </a:p>
         </p:txBody>
       </p:sp>

</xml_diff>